<commit_message>
feat: remove white border on arrows
</commit_message>
<xml_diff>
--- a/docs/figures/pptx/github-intro.pptx
+++ b/docs/figures/pptx/github-intro.pptx
@@ -5826,7 +5826,9 @@
           <a:solidFill>
             <a:schemeClr val="accent3"/>
           </a:solidFill>
-          <a:ln/>
+          <a:ln>
+            <a:noFill/>
+          </a:ln>
           <a:effectLst/>
         </p:spPr>
         <p:style>
@@ -5888,7 +5890,9 @@
           <a:solidFill>
             <a:schemeClr val="accent3"/>
           </a:solidFill>
-          <a:ln/>
+          <a:ln>
+            <a:noFill/>
+          </a:ln>
           <a:effectLst/>
         </p:spPr>
         <p:style>
@@ -6142,10 +6146,10 @@
         </p:nvGrpSpPr>
         <p:grpSpPr>
           <a:xfrm rot="5400000">
-            <a:off x="6591" y="787733"/>
-            <a:ext cx="1439512" cy="833444"/>
-            <a:chOff x="466417" y="1972233"/>
-            <a:chExt cx="1249552" cy="833444"/>
+            <a:off x="-16751" y="811074"/>
+            <a:ext cx="1484861" cy="832110"/>
+            <a:chOff x="466417" y="1973567"/>
+            <a:chExt cx="1288917" cy="832110"/>
           </a:xfrm>
         </p:grpSpPr>
         <p:sp>
@@ -6177,7 +6181,9 @@
             <a:solidFill>
               <a:schemeClr val="accent3"/>
             </a:solidFill>
-            <a:ln/>
+            <a:ln>
+              <a:noFill/>
+            </a:ln>
             <a:effectLst/>
           </p:spPr>
           <p:style>
@@ -6273,7 +6279,7 @@
           </p:nvSpPr>
           <p:spPr>
             <a:xfrm>
-              <a:off x="1180550" y="1972233"/>
+              <a:off x="1219915" y="1973567"/>
               <a:ext cx="535419" cy="276528"/>
             </a:xfrm>
             <a:prstGeom prst="triangle">

</xml_diff>